<commit_message>
Reorganized and added Task 3 files
</commit_message>
<xml_diff>
--- a/Task 1/INTERNET AND MOBILE PROGRAMMING.pptx
+++ b/Task 1/INTERNET AND MOBILE PROGRAMMING.pptx
@@ -11915,7 +11915,7 @@
         </p:nvSpPr>
         <p:spPr>
           <a:xfrm>
-            <a:off x="1352425" y="1972407"/>
+            <a:off x="1352425" y="2700703"/>
             <a:ext cx="10018713" cy="1456594"/>
           </a:xfrm>
         </p:spPr>
@@ -11924,6 +11924,9 @@
           <a:lstStyle/>
           <a:p>
             <a:pPr marL="0" indent="0">
+              <a:lnSpc>
+                <a:spcPct val="150000"/>
+              </a:lnSpc>
               <a:buNone/>
             </a:pPr>
             <a:r>

</xml_diff>